<commit_message>
updating for fall 2026
</commit_message>
<xml_diff>
--- a/Lectures/01-ClassOverview.pptx
+++ b/Lectures/01-ClassOverview.pptx
@@ -285,7 +285,7 @@
 </file>
 
 <file path=ppt/diagrams/colors1.xml><?xml version="1.0" encoding="utf-8"?>
-<dgm:colorsDef xmlns:dgm="http://schemas.openxmlformats.org/drawingml/2006/diagram" xmlns:a="http://schemas.openxmlformats.org/drawingml/2006/main" uniqueId="urn:microsoft.com/office/officeart/2005/8/colors/colorful1">
+<dgm:colorsDef xmlns:dgm="http://schemas.openxmlformats.org/drawingml/2006/diagram" xmlns:a="http://schemas.openxmlformats.org/drawingml/2006/main" uniqueId="urn:microsoft.com/office/officeart/2005/8/colors/colorful1#1">
   <dgm:title val=""/>
   <dgm:desc val=""/>
   <dgm:catLst>
@@ -1207,7 +1207,7 @@
 <dgm:dataModel xmlns:dgm="http://schemas.openxmlformats.org/drawingml/2006/diagram" xmlns:a="http://schemas.openxmlformats.org/drawingml/2006/main">
   <dgm:ptLst>
     <dgm:pt modelId="{E9FB0F4E-6967-3B44-A32F-E8B1C7AE98D5}" type="doc">
-      <dgm:prSet loTypeId="urn:microsoft.com/office/officeart/2005/8/layout/process5" loCatId="" qsTypeId="urn:microsoft.com/office/officeart/2005/8/quickstyle/simple1" qsCatId="simple" csTypeId="urn:microsoft.com/office/officeart/2005/8/colors/colorful1" csCatId="colorful" phldr="1"/>
+      <dgm:prSet loTypeId="urn:microsoft.com/office/officeart/2005/8/layout/process5" loCatId="" qsTypeId="urn:microsoft.com/office/officeart/2005/8/quickstyle/simple1#1" qsCatId="simple" csTypeId="urn:microsoft.com/office/officeart/2005/8/colors/colorful1#1" csCatId="colorful" phldr="1"/>
       <dgm:spPr/>
       <dgm:t>
         <a:bodyPr/>
@@ -4256,7 +4256,7 @@
 </file>
 
 <file path=ppt/diagrams/quickStyle1.xml><?xml version="1.0" encoding="utf-8"?>
-<dgm:styleDef xmlns:dgm="http://schemas.openxmlformats.org/drawingml/2006/diagram" xmlns:a="http://schemas.openxmlformats.org/drawingml/2006/main" uniqueId="urn:microsoft.com/office/officeart/2005/8/quickstyle/simple1">
+<dgm:styleDef xmlns:dgm="http://schemas.openxmlformats.org/drawingml/2006/diagram" xmlns:a="http://schemas.openxmlformats.org/drawingml/2006/main" uniqueId="urn:microsoft.com/office/officeart/2005/8/quickstyle/simple1#1">
   <dgm:title val=""/>
   <dgm:desc val=""/>
   <dgm:catLst>
@@ -12209,8 +12209,15 @@
               <a:buNone/>
             </a:pPr>
             <a:r>
+              <a:rPr lang="en" sz="4800" dirty="0"/>
+              <a:t>Machine Learning in Practice</a:t>
+            </a:r>
+            <a:br>
               <a:rPr lang="en" sz="4400" dirty="0"/>
-              <a:t>Machine Learning for Public Policy Lab</a:t>
+            </a:br>
+            <a:r>
+              <a:rPr lang="en" sz="4000" dirty="0"/>
+              <a:t>(for Social Good and Public Policy)</a:t>
             </a:r>
             <a:endParaRPr sz="3200" dirty="0"/>
           </a:p>
@@ -12808,12 +12815,20 @@
               <a:buSzPts val="1600"/>
             </a:pPr>
             <a:r>
+              <a:rPr lang="en-US" sz="1600" dirty="0">
+                <a:solidFill>
+                  <a:schemeClr val="dk1"/>
+                </a:solidFill>
+              </a:rPr>
+              <a:t>L</a:t>
+            </a:r>
+            <a:r>
               <a:rPr lang="en" sz="1600" dirty="0">
                 <a:solidFill>
                   <a:schemeClr val="dk1"/>
                 </a:solidFill>
               </a:rPr>
-              <a:t>Wednesday tech and review sessions</a:t>
+              <a:t>ab/tech and review sessions</a:t>
             </a:r>
             <a:endParaRPr lang="en" sz="1600" b="1" dirty="0">
               <a:solidFill>
@@ -14211,18 +14226,26 @@
             </a:pPr>
             <a:r>
               <a:rPr lang="en" dirty="0"/>
-              <a:t>Tech setup (tomorrow) </a:t>
+              <a:t>Tech setup (</a:t>
+            </a:r>
+            <a:r>
+              <a:rPr lang="en" dirty="0" err="1"/>
+              <a:t>friday</a:t>
+            </a:r>
+            <a:r>
+              <a:rPr lang="en" dirty="0"/>
+              <a:t>) </a:t>
             </a:r>
           </a:p>
           <a:p>
             <a:pPr lvl="1"/>
             <a:r>
               <a:rPr lang="en-US" dirty="0"/>
-              <a:t>Make sure to fill out the survey by this afternoo</a:t>
+              <a:t>Make sure to fill out the survey by tomorrow </a:t>
             </a:r>
             <a:r>
               <a:rPr lang="en-US" sz="1000" dirty="0"/>
-              <a:t>n - </a:t>
+              <a:t>- </a:t>
             </a:r>
             <a:r>
               <a:rPr lang="en-US" sz="1200" dirty="0"/>
@@ -14508,7 +14531,7 @@
             </a:r>
             <a:r>
               <a:rPr lang="en-US" sz="1600" dirty="0"/>
-              <a:t>(and get hands-on experience doing most of it)</a:t>
+              <a:t>(and get hands-on experience doing a lot of it)</a:t>
             </a:r>
           </a:p>
           <a:p>
@@ -14768,7 +14791,7 @@
             </a:pPr>
             <a:r>
               <a:rPr lang="en" dirty="0"/>
-              <a:t>Experience with command line (bash), git(hub), working on remote servers</a:t>
+              <a:t>Ideally: Experience with command line (bash), git(hub), working on remote servers</a:t>
             </a:r>
           </a:p>
           <a:p>

</xml_diff>